<commit_message>
Update presentation files for Weeks 1 to 6; revise content and remove obsolete files
</commit_message>
<xml_diff>
--- a/Woche_6_Projektstart/Woche_6_Projektstart_v01.pptx
+++ b/Woche_6_Projektstart/Woche_6_Projektstart_v01.pptx
@@ -169,7 +169,7 @@
 <file path=ppt/revisionInfo.xml><?xml version="1.0" encoding="utf-8"?>
 <p1510:revInfo xmlns:a="http://schemas.openxmlformats.org/drawingml/2006/main" xmlns:r="http://schemas.openxmlformats.org/officeDocument/2006/relationships" xmlns:p1510="http://schemas.microsoft.com/office/powerpoint/2015/10/main">
   <p1510:revLst>
-    <p1510:client id="{B2BB12B1-FB4E-4F31-87A7-6AA76B32EA74}" v="19" dt="2026-04-21T11:21:37.330"/>
+    <p1510:client id="{B1F127F4-DEC5-41D9-977A-3B1282D851A9}" v="2" dt="2026-04-23T14:17:39.921"/>
   </p1510:revLst>
 </p1510:revInfo>
 </file>
@@ -183,300 +183,6 @@
       <pc:docMkLst>
         <pc:docMk/>
       </pc:docMkLst>
-      <pc:sldChg chg="del">
-        <pc:chgData name="Peter Bernhardt" userId="f2333933-0b12-4d6e-972f-f87625423892" providerId="ADAL" clId="{2C628E33-589C-449E-BBA5-ED05E3E5CC01}" dt="2026-04-21T08:37:37.791" v="1" actId="47"/>
-        <pc:sldMkLst>
-          <pc:docMk/>
-          <pc:sldMk cId="0" sldId="256"/>
-        </pc:sldMkLst>
-      </pc:sldChg>
-      <pc:sldChg chg="del">
-        <pc:chgData name="Peter Bernhardt" userId="f2333933-0b12-4d6e-972f-f87625423892" providerId="ADAL" clId="{2C628E33-589C-449E-BBA5-ED05E3E5CC01}" dt="2026-04-21T08:37:37.791" v="1" actId="47"/>
-        <pc:sldMkLst>
-          <pc:docMk/>
-          <pc:sldMk cId="0" sldId="257"/>
-        </pc:sldMkLst>
-      </pc:sldChg>
-      <pc:sldChg chg="del">
-        <pc:chgData name="Peter Bernhardt" userId="f2333933-0b12-4d6e-972f-f87625423892" providerId="ADAL" clId="{2C628E33-589C-449E-BBA5-ED05E3E5CC01}" dt="2026-04-21T08:37:37.791" v="1" actId="47"/>
-        <pc:sldMkLst>
-          <pc:docMk/>
-          <pc:sldMk cId="0" sldId="258"/>
-        </pc:sldMkLst>
-      </pc:sldChg>
-      <pc:sldChg chg="del">
-        <pc:chgData name="Peter Bernhardt" userId="f2333933-0b12-4d6e-972f-f87625423892" providerId="ADAL" clId="{2C628E33-589C-449E-BBA5-ED05E3E5CC01}" dt="2026-04-21T08:37:37.791" v="1" actId="47"/>
-        <pc:sldMkLst>
-          <pc:docMk/>
-          <pc:sldMk cId="0" sldId="259"/>
-        </pc:sldMkLst>
-      </pc:sldChg>
-      <pc:sldChg chg="del">
-        <pc:chgData name="Peter Bernhardt" userId="f2333933-0b12-4d6e-972f-f87625423892" providerId="ADAL" clId="{2C628E33-589C-449E-BBA5-ED05E3E5CC01}" dt="2026-04-21T08:37:37.791" v="1" actId="47"/>
-        <pc:sldMkLst>
-          <pc:docMk/>
-          <pc:sldMk cId="0" sldId="260"/>
-        </pc:sldMkLst>
-      </pc:sldChg>
-      <pc:sldChg chg="del">
-        <pc:chgData name="Peter Bernhardt" userId="f2333933-0b12-4d6e-972f-f87625423892" providerId="ADAL" clId="{2C628E33-589C-449E-BBA5-ED05E3E5CC01}" dt="2026-04-21T08:37:37.791" v="1" actId="47"/>
-        <pc:sldMkLst>
-          <pc:docMk/>
-          <pc:sldMk cId="0" sldId="261"/>
-        </pc:sldMkLst>
-      </pc:sldChg>
-      <pc:sldChg chg="del">
-        <pc:chgData name="Peter Bernhardt" userId="f2333933-0b12-4d6e-972f-f87625423892" providerId="ADAL" clId="{2C628E33-589C-449E-BBA5-ED05E3E5CC01}" dt="2026-04-21T08:37:37.791" v="1" actId="47"/>
-        <pc:sldMkLst>
-          <pc:docMk/>
-          <pc:sldMk cId="0" sldId="262"/>
-        </pc:sldMkLst>
-      </pc:sldChg>
-      <pc:sldChg chg="del">
-        <pc:chgData name="Peter Bernhardt" userId="f2333933-0b12-4d6e-972f-f87625423892" providerId="ADAL" clId="{2C628E33-589C-449E-BBA5-ED05E3E5CC01}" dt="2026-04-21T08:37:37.791" v="1" actId="47"/>
-        <pc:sldMkLst>
-          <pc:docMk/>
-          <pc:sldMk cId="0" sldId="263"/>
-        </pc:sldMkLst>
-      </pc:sldChg>
-      <pc:sldChg chg="del">
-        <pc:chgData name="Peter Bernhardt" userId="f2333933-0b12-4d6e-972f-f87625423892" providerId="ADAL" clId="{2C628E33-589C-449E-BBA5-ED05E3E5CC01}" dt="2026-04-21T08:37:37.791" v="1" actId="47"/>
-        <pc:sldMkLst>
-          <pc:docMk/>
-          <pc:sldMk cId="0" sldId="264"/>
-        </pc:sldMkLst>
-      </pc:sldChg>
-      <pc:sldChg chg="del">
-        <pc:chgData name="Peter Bernhardt" userId="f2333933-0b12-4d6e-972f-f87625423892" providerId="ADAL" clId="{2C628E33-589C-449E-BBA5-ED05E3E5CC01}" dt="2026-04-21T08:37:37.791" v="1" actId="47"/>
-        <pc:sldMkLst>
-          <pc:docMk/>
-          <pc:sldMk cId="0" sldId="265"/>
-        </pc:sldMkLst>
-      </pc:sldChg>
-      <pc:sldChg chg="del">
-        <pc:chgData name="Peter Bernhardt" userId="f2333933-0b12-4d6e-972f-f87625423892" providerId="ADAL" clId="{2C628E33-589C-449E-BBA5-ED05E3E5CC01}" dt="2026-04-21T08:37:37.791" v="1" actId="47"/>
-        <pc:sldMkLst>
-          <pc:docMk/>
-          <pc:sldMk cId="0" sldId="266"/>
-        </pc:sldMkLst>
-      </pc:sldChg>
-      <pc:sldChg chg="del">
-        <pc:chgData name="Peter Bernhardt" userId="f2333933-0b12-4d6e-972f-f87625423892" providerId="ADAL" clId="{2C628E33-589C-449E-BBA5-ED05E3E5CC01}" dt="2026-04-21T08:37:37.791" v="1" actId="47"/>
-        <pc:sldMkLst>
-          <pc:docMk/>
-          <pc:sldMk cId="0" sldId="267"/>
-        </pc:sldMkLst>
-      </pc:sldChg>
-      <pc:sldChg chg="del">
-        <pc:chgData name="Peter Bernhardt" userId="f2333933-0b12-4d6e-972f-f87625423892" providerId="ADAL" clId="{2C628E33-589C-449E-BBA5-ED05E3E5CC01}" dt="2026-04-21T08:37:37.791" v="1" actId="47"/>
-        <pc:sldMkLst>
-          <pc:docMk/>
-          <pc:sldMk cId="0" sldId="268"/>
-        </pc:sldMkLst>
-      </pc:sldChg>
-      <pc:sldChg chg="del">
-        <pc:chgData name="Peter Bernhardt" userId="f2333933-0b12-4d6e-972f-f87625423892" providerId="ADAL" clId="{2C628E33-589C-449E-BBA5-ED05E3E5CC01}" dt="2026-04-21T08:37:37.791" v="1" actId="47"/>
-        <pc:sldMkLst>
-          <pc:docMk/>
-          <pc:sldMk cId="0" sldId="269"/>
-        </pc:sldMkLst>
-      </pc:sldChg>
-      <pc:sldChg chg="del">
-        <pc:chgData name="Peter Bernhardt" userId="f2333933-0b12-4d6e-972f-f87625423892" providerId="ADAL" clId="{2C628E33-589C-449E-BBA5-ED05E3E5CC01}" dt="2026-04-21T08:37:37.791" v="1" actId="47"/>
-        <pc:sldMkLst>
-          <pc:docMk/>
-          <pc:sldMk cId="0" sldId="270"/>
-        </pc:sldMkLst>
-      </pc:sldChg>
-      <pc:sldChg chg="del">
-        <pc:chgData name="Peter Bernhardt" userId="f2333933-0b12-4d6e-972f-f87625423892" providerId="ADAL" clId="{2C628E33-589C-449E-BBA5-ED05E3E5CC01}" dt="2026-04-21T08:37:37.791" v="1" actId="47"/>
-        <pc:sldMkLst>
-          <pc:docMk/>
-          <pc:sldMk cId="0" sldId="271"/>
-        </pc:sldMkLst>
-      </pc:sldChg>
-      <pc:sldChg chg="del">
-        <pc:chgData name="Peter Bernhardt" userId="f2333933-0b12-4d6e-972f-f87625423892" providerId="ADAL" clId="{2C628E33-589C-449E-BBA5-ED05E3E5CC01}" dt="2026-04-21T08:37:37.791" v="1" actId="47"/>
-        <pc:sldMkLst>
-          <pc:docMk/>
-          <pc:sldMk cId="0" sldId="272"/>
-        </pc:sldMkLst>
-      </pc:sldChg>
-      <pc:sldChg chg="del">
-        <pc:chgData name="Peter Bernhardt" userId="f2333933-0b12-4d6e-972f-f87625423892" providerId="ADAL" clId="{2C628E33-589C-449E-BBA5-ED05E3E5CC01}" dt="2026-04-21T08:37:37.791" v="1" actId="47"/>
-        <pc:sldMkLst>
-          <pc:docMk/>
-          <pc:sldMk cId="0" sldId="273"/>
-        </pc:sldMkLst>
-      </pc:sldChg>
-      <pc:sldChg chg="del">
-        <pc:chgData name="Peter Bernhardt" userId="f2333933-0b12-4d6e-972f-f87625423892" providerId="ADAL" clId="{2C628E33-589C-449E-BBA5-ED05E3E5CC01}" dt="2026-04-21T08:37:37.791" v="1" actId="47"/>
-        <pc:sldMkLst>
-          <pc:docMk/>
-          <pc:sldMk cId="0" sldId="274"/>
-        </pc:sldMkLst>
-      </pc:sldChg>
-      <pc:sldChg chg="del">
-        <pc:chgData name="Peter Bernhardt" userId="f2333933-0b12-4d6e-972f-f87625423892" providerId="ADAL" clId="{2C628E33-589C-449E-BBA5-ED05E3E5CC01}" dt="2026-04-21T08:37:37.791" v="1" actId="47"/>
-        <pc:sldMkLst>
-          <pc:docMk/>
-          <pc:sldMk cId="0" sldId="275"/>
-        </pc:sldMkLst>
-      </pc:sldChg>
-      <pc:sldChg chg="del">
-        <pc:chgData name="Peter Bernhardt" userId="f2333933-0b12-4d6e-972f-f87625423892" providerId="ADAL" clId="{2C628E33-589C-449E-BBA5-ED05E3E5CC01}" dt="2026-04-21T08:37:37.791" v="1" actId="47"/>
-        <pc:sldMkLst>
-          <pc:docMk/>
-          <pc:sldMk cId="0" sldId="276"/>
-        </pc:sldMkLst>
-      </pc:sldChg>
-      <pc:sldChg chg="del">
-        <pc:chgData name="Peter Bernhardt" userId="f2333933-0b12-4d6e-972f-f87625423892" providerId="ADAL" clId="{2C628E33-589C-449E-BBA5-ED05E3E5CC01}" dt="2026-04-21T08:37:37.791" v="1" actId="47"/>
-        <pc:sldMkLst>
-          <pc:docMk/>
-          <pc:sldMk cId="0" sldId="277"/>
-        </pc:sldMkLst>
-      </pc:sldChg>
-      <pc:sldChg chg="del">
-        <pc:chgData name="Peter Bernhardt" userId="f2333933-0b12-4d6e-972f-f87625423892" providerId="ADAL" clId="{2C628E33-589C-449E-BBA5-ED05E3E5CC01}" dt="2026-04-21T08:37:37.791" v="1" actId="47"/>
-        <pc:sldMkLst>
-          <pc:docMk/>
-          <pc:sldMk cId="0" sldId="278"/>
-        </pc:sldMkLst>
-      </pc:sldChg>
-      <pc:sldChg chg="del">
-        <pc:chgData name="Peter Bernhardt" userId="f2333933-0b12-4d6e-972f-f87625423892" providerId="ADAL" clId="{2C628E33-589C-449E-BBA5-ED05E3E5CC01}" dt="2026-04-21T08:37:37.791" v="1" actId="47"/>
-        <pc:sldMkLst>
-          <pc:docMk/>
-          <pc:sldMk cId="0" sldId="279"/>
-        </pc:sldMkLst>
-      </pc:sldChg>
-      <pc:sldChg chg="del">
-        <pc:chgData name="Peter Bernhardt" userId="f2333933-0b12-4d6e-972f-f87625423892" providerId="ADAL" clId="{2C628E33-589C-449E-BBA5-ED05E3E5CC01}" dt="2026-04-21T08:37:37.791" v="1" actId="47"/>
-        <pc:sldMkLst>
-          <pc:docMk/>
-          <pc:sldMk cId="0" sldId="280"/>
-        </pc:sldMkLst>
-      </pc:sldChg>
-      <pc:sldChg chg="del">
-        <pc:chgData name="Peter Bernhardt" userId="f2333933-0b12-4d6e-972f-f87625423892" providerId="ADAL" clId="{2C628E33-589C-449E-BBA5-ED05E3E5CC01}" dt="2026-04-21T08:37:37.791" v="1" actId="47"/>
-        <pc:sldMkLst>
-          <pc:docMk/>
-          <pc:sldMk cId="0" sldId="281"/>
-        </pc:sldMkLst>
-      </pc:sldChg>
-      <pc:sldChg chg="del">
-        <pc:chgData name="Peter Bernhardt" userId="f2333933-0b12-4d6e-972f-f87625423892" providerId="ADAL" clId="{2C628E33-589C-449E-BBA5-ED05E3E5CC01}" dt="2026-04-21T08:37:37.791" v="1" actId="47"/>
-        <pc:sldMkLst>
-          <pc:docMk/>
-          <pc:sldMk cId="0" sldId="282"/>
-        </pc:sldMkLst>
-      </pc:sldChg>
-      <pc:sldChg chg="del">
-        <pc:chgData name="Peter Bernhardt" userId="f2333933-0b12-4d6e-972f-f87625423892" providerId="ADAL" clId="{2C628E33-589C-449E-BBA5-ED05E3E5CC01}" dt="2026-04-21T08:37:37.791" v="1" actId="47"/>
-        <pc:sldMkLst>
-          <pc:docMk/>
-          <pc:sldMk cId="0" sldId="283"/>
-        </pc:sldMkLst>
-      </pc:sldChg>
-      <pc:sldChg chg="del">
-        <pc:chgData name="Peter Bernhardt" userId="f2333933-0b12-4d6e-972f-f87625423892" providerId="ADAL" clId="{2C628E33-589C-449E-BBA5-ED05E3E5CC01}" dt="2026-04-21T08:37:37.791" v="1" actId="47"/>
-        <pc:sldMkLst>
-          <pc:docMk/>
-          <pc:sldMk cId="0" sldId="284"/>
-        </pc:sldMkLst>
-      </pc:sldChg>
-      <pc:sldChg chg="del">
-        <pc:chgData name="Peter Bernhardt" userId="f2333933-0b12-4d6e-972f-f87625423892" providerId="ADAL" clId="{2C628E33-589C-449E-BBA5-ED05E3E5CC01}" dt="2026-04-21T08:37:37.791" v="1" actId="47"/>
-        <pc:sldMkLst>
-          <pc:docMk/>
-          <pc:sldMk cId="0" sldId="285"/>
-        </pc:sldMkLst>
-      </pc:sldChg>
-      <pc:sldChg chg="del">
-        <pc:chgData name="Peter Bernhardt" userId="f2333933-0b12-4d6e-972f-f87625423892" providerId="ADAL" clId="{2C628E33-589C-449E-BBA5-ED05E3E5CC01}" dt="2026-04-21T08:37:37.791" v="1" actId="47"/>
-        <pc:sldMkLst>
-          <pc:docMk/>
-          <pc:sldMk cId="0" sldId="286"/>
-        </pc:sldMkLst>
-      </pc:sldChg>
-      <pc:sldChg chg="del">
-        <pc:chgData name="Peter Bernhardt" userId="f2333933-0b12-4d6e-972f-f87625423892" providerId="ADAL" clId="{2C628E33-589C-449E-BBA5-ED05E3E5CC01}" dt="2026-04-21T08:37:37.791" v="1" actId="47"/>
-        <pc:sldMkLst>
-          <pc:docMk/>
-          <pc:sldMk cId="0" sldId="287"/>
-        </pc:sldMkLst>
-      </pc:sldChg>
-      <pc:sldChg chg="del">
-        <pc:chgData name="Peter Bernhardt" userId="f2333933-0b12-4d6e-972f-f87625423892" providerId="ADAL" clId="{2C628E33-589C-449E-BBA5-ED05E3E5CC01}" dt="2026-04-21T08:37:37.791" v="1" actId="47"/>
-        <pc:sldMkLst>
-          <pc:docMk/>
-          <pc:sldMk cId="0" sldId="288"/>
-        </pc:sldMkLst>
-      </pc:sldChg>
-      <pc:sldChg chg="del">
-        <pc:chgData name="Peter Bernhardt" userId="f2333933-0b12-4d6e-972f-f87625423892" providerId="ADAL" clId="{2C628E33-589C-449E-BBA5-ED05E3E5CC01}" dt="2026-04-21T08:37:37.791" v="1" actId="47"/>
-        <pc:sldMkLst>
-          <pc:docMk/>
-          <pc:sldMk cId="0" sldId="289"/>
-        </pc:sldMkLst>
-      </pc:sldChg>
-      <pc:sldChg chg="del">
-        <pc:chgData name="Peter Bernhardt" userId="f2333933-0b12-4d6e-972f-f87625423892" providerId="ADAL" clId="{2C628E33-589C-449E-BBA5-ED05E3E5CC01}" dt="2026-04-21T08:37:37.791" v="1" actId="47"/>
-        <pc:sldMkLst>
-          <pc:docMk/>
-          <pc:sldMk cId="0" sldId="290"/>
-        </pc:sldMkLst>
-      </pc:sldChg>
-      <pc:sldChg chg="del">
-        <pc:chgData name="Peter Bernhardt" userId="f2333933-0b12-4d6e-972f-f87625423892" providerId="ADAL" clId="{2C628E33-589C-449E-BBA5-ED05E3E5CC01}" dt="2026-04-21T08:37:37.791" v="1" actId="47"/>
-        <pc:sldMkLst>
-          <pc:docMk/>
-          <pc:sldMk cId="0" sldId="291"/>
-        </pc:sldMkLst>
-      </pc:sldChg>
-      <pc:sldChg chg="del">
-        <pc:chgData name="Peter Bernhardt" userId="f2333933-0b12-4d6e-972f-f87625423892" providerId="ADAL" clId="{2C628E33-589C-449E-BBA5-ED05E3E5CC01}" dt="2026-04-21T08:37:37.791" v="1" actId="47"/>
-        <pc:sldMkLst>
-          <pc:docMk/>
-          <pc:sldMk cId="0" sldId="292"/>
-        </pc:sldMkLst>
-      </pc:sldChg>
-      <pc:sldChg chg="del">
-        <pc:chgData name="Peter Bernhardt" userId="f2333933-0b12-4d6e-972f-f87625423892" providerId="ADAL" clId="{2C628E33-589C-449E-BBA5-ED05E3E5CC01}" dt="2026-04-21T08:37:37.791" v="1" actId="47"/>
-        <pc:sldMkLst>
-          <pc:docMk/>
-          <pc:sldMk cId="1813317568" sldId="294"/>
-        </pc:sldMkLst>
-      </pc:sldChg>
-      <pc:sldChg chg="del">
-        <pc:chgData name="Peter Bernhardt" userId="f2333933-0b12-4d6e-972f-f87625423892" providerId="ADAL" clId="{2C628E33-589C-449E-BBA5-ED05E3E5CC01}" dt="2026-04-21T08:37:37.791" v="1" actId="47"/>
-        <pc:sldMkLst>
-          <pc:docMk/>
-          <pc:sldMk cId="3043209551" sldId="295"/>
-        </pc:sldMkLst>
-      </pc:sldChg>
-      <pc:sldChg chg="del">
-        <pc:chgData name="Peter Bernhardt" userId="f2333933-0b12-4d6e-972f-f87625423892" providerId="ADAL" clId="{2C628E33-589C-449E-BBA5-ED05E3E5CC01}" dt="2026-04-21T08:37:37.791" v="1" actId="47"/>
-        <pc:sldMkLst>
-          <pc:docMk/>
-          <pc:sldMk cId="1123959644" sldId="296"/>
-        </pc:sldMkLst>
-      </pc:sldChg>
-      <pc:sldChg chg="del">
-        <pc:chgData name="Peter Bernhardt" userId="f2333933-0b12-4d6e-972f-f87625423892" providerId="ADAL" clId="{2C628E33-589C-449E-BBA5-ED05E3E5CC01}" dt="2026-04-21T08:37:37.791" v="1" actId="47"/>
-        <pc:sldMkLst>
-          <pc:docMk/>
-          <pc:sldMk cId="1863045288" sldId="297"/>
-        </pc:sldMkLst>
-      </pc:sldChg>
-      <pc:sldChg chg="del">
-        <pc:chgData name="Peter Bernhardt" userId="f2333933-0b12-4d6e-972f-f87625423892" providerId="ADAL" clId="{2C628E33-589C-449E-BBA5-ED05E3E5CC01}" dt="2026-04-21T08:37:37.791" v="1" actId="47"/>
-        <pc:sldMkLst>
-          <pc:docMk/>
-          <pc:sldMk cId="1538975160" sldId="298"/>
-        </pc:sldMkLst>
-      </pc:sldChg>
       <pc:sldChg chg="addSp delSp modSp add mod chgLayout">
         <pc:chgData name="Peter Bernhardt" userId="f2333933-0b12-4d6e-972f-f87625423892" providerId="ADAL" clId="{2C628E33-589C-449E-BBA5-ED05E3E5CC01}" dt="2026-04-21T08:37:51.433" v="9" actId="20577"/>
         <pc:sldMkLst>
@@ -507,30 +213,6 @@
             <ac:spMk id="4" creationId="{00000000-0000-0000-0000-000000000000}"/>
           </ac:spMkLst>
         </pc:spChg>
-        <pc:spChg chg="add del mod">
-          <ac:chgData name="Peter Bernhardt" userId="f2333933-0b12-4d6e-972f-f87625423892" providerId="ADAL" clId="{2C628E33-589C-449E-BBA5-ED05E3E5CC01}" dt="2026-04-21T08:37:48.614" v="2" actId="6264"/>
-          <ac:spMkLst>
-            <pc:docMk/>
-            <pc:sldMk cId="0" sldId="299"/>
-            <ac:spMk id="5" creationId="{5216F69E-3EEF-CADA-1FCC-CD57E5DC2EFA}"/>
-          </ac:spMkLst>
-        </pc:spChg>
-        <pc:spChg chg="add del mod">
-          <ac:chgData name="Peter Bernhardt" userId="f2333933-0b12-4d6e-972f-f87625423892" providerId="ADAL" clId="{2C628E33-589C-449E-BBA5-ED05E3E5CC01}" dt="2026-04-21T08:37:48.614" v="2" actId="6264"/>
-          <ac:spMkLst>
-            <pc:docMk/>
-            <pc:sldMk cId="0" sldId="299"/>
-            <ac:spMk id="6" creationId="{38EE3C09-958D-2E5E-0BA0-2EB0534EE1C5}"/>
-          </ac:spMkLst>
-        </pc:spChg>
-        <pc:spChg chg="add del mod">
-          <ac:chgData name="Peter Bernhardt" userId="f2333933-0b12-4d6e-972f-f87625423892" providerId="ADAL" clId="{2C628E33-589C-449E-BBA5-ED05E3E5CC01}" dt="2026-04-21T08:37:48.614" v="2" actId="6264"/>
-          <ac:spMkLst>
-            <pc:docMk/>
-            <pc:sldMk cId="0" sldId="299"/>
-            <ac:spMk id="7" creationId="{30D48EDB-C392-0641-93D4-48530AD472E4}"/>
-          </ac:spMkLst>
-        </pc:spChg>
       </pc:sldChg>
       <pc:sldChg chg="addSp delSp modSp add mod chgLayout">
         <pc:chgData name="Peter Bernhardt" userId="f2333933-0b12-4d6e-972f-f87625423892" providerId="ADAL" clId="{2C628E33-589C-449E-BBA5-ED05E3E5CC01}" dt="2026-04-21T08:38:00.793" v="12" actId="20577"/>
@@ -544,14 +226,6 @@
             <pc:docMk/>
             <pc:sldMk cId="0" sldId="300"/>
             <ac:spMk id="2" creationId="{00000000-0000-0000-0000-000000000000}"/>
-          </ac:spMkLst>
-        </pc:spChg>
-        <pc:spChg chg="add del mod">
-          <ac:chgData name="Peter Bernhardt" userId="f2333933-0b12-4d6e-972f-f87625423892" providerId="ADAL" clId="{2C628E33-589C-449E-BBA5-ED05E3E5CC01}" dt="2026-04-21T08:37:57.801" v="10" actId="6264"/>
-          <ac:spMkLst>
-            <pc:docMk/>
-            <pc:sldMk cId="0" sldId="300"/>
-            <ac:spMk id="3" creationId="{049CDC3A-D22E-9CEE-23F8-64D9AC1D7D69}"/>
           </ac:spMkLst>
         </pc:spChg>
         <pc:spChg chg="add mod ord">
@@ -651,14 +325,6 @@
             <pc:docMk/>
             <pc:sldMk cId="0" sldId="305"/>
             <ac:spMk id="2" creationId="{00000000-0000-0000-0000-000000000000}"/>
-          </ac:spMkLst>
-        </pc:spChg>
-        <pc:spChg chg="add del mod">
-          <ac:chgData name="Peter Bernhardt" userId="f2333933-0b12-4d6e-972f-f87625423892" providerId="ADAL" clId="{2C628E33-589C-449E-BBA5-ED05E3E5CC01}" dt="2026-04-21T08:38:28.062" v="17" actId="6264"/>
-          <ac:spMkLst>
-            <pc:docMk/>
-            <pc:sldMk cId="0" sldId="305"/>
-            <ac:spMk id="3" creationId="{F2DCD104-36B5-913C-2B99-BEA608611283}"/>
           </ac:spMkLst>
         </pc:spChg>
         <pc:spChg chg="add mod ord">
@@ -790,14 +456,6 @@
           <pc:docMk/>
           <pc:sldMk cId="0" sldId="312"/>
         </pc:sldMkLst>
-        <pc:spChg chg="del mod">
-          <ac:chgData name="Peter Bernhardt" userId="f2333933-0b12-4d6e-972f-f87625423892" providerId="ADAL" clId="{2C628E33-589C-449E-BBA5-ED05E3E5CC01}" dt="2026-04-21T09:48:39.320" v="1209" actId="478"/>
-          <ac:spMkLst>
-            <pc:docMk/>
-            <pc:sldMk cId="0" sldId="312"/>
-            <ac:spMk id="3" creationId="{00000000-0000-0000-0000-000000000000}"/>
-          </ac:spMkLst>
-        </pc:spChg>
         <pc:spChg chg="add mod">
           <ac:chgData name="Peter Bernhardt" userId="f2333933-0b12-4d6e-972f-f87625423892" providerId="ADAL" clId="{2C628E33-589C-449E-BBA5-ED05E3E5CC01}" dt="2026-04-21T09:49:37.023" v="1232" actId="1076"/>
           <ac:spMkLst>
@@ -859,14 +517,6 @@
             <ac:spMk id="2" creationId="{00000000-0000-0000-0000-000000000000}"/>
           </ac:spMkLst>
         </pc:spChg>
-        <pc:spChg chg="add del mod">
-          <ac:chgData name="Peter Bernhardt" userId="f2333933-0b12-4d6e-972f-f87625423892" providerId="ADAL" clId="{2C628E33-589C-449E-BBA5-ED05E3E5CC01}" dt="2026-04-21T08:39:38.271" v="33" actId="6264"/>
-          <ac:spMkLst>
-            <pc:docMk/>
-            <pc:sldMk cId="0" sldId="315"/>
-            <ac:spMk id="3" creationId="{AFCB19F3-C664-0271-FEEA-D99BBB3CC61B}"/>
-          </ac:spMkLst>
-        </pc:spChg>
         <pc:spChg chg="add mod ord">
           <ac:chgData name="Peter Bernhardt" userId="f2333933-0b12-4d6e-972f-f87625423892" providerId="ADAL" clId="{2C628E33-589C-449E-BBA5-ED05E3E5CC01}" dt="2026-04-21T08:39:38.271" v="33" actId="6264"/>
           <ac:spMkLst>
@@ -896,14 +546,6 @@
             <pc:docMk/>
             <pc:sldMk cId="0" sldId="316"/>
             <ac:spMk id="3" creationId="{00000000-0000-0000-0000-000000000000}"/>
-          </ac:spMkLst>
-        </pc:spChg>
-        <pc:spChg chg="add del mod">
-          <ac:chgData name="Peter Bernhardt" userId="f2333933-0b12-4d6e-972f-f87625423892" providerId="ADAL" clId="{2C628E33-589C-449E-BBA5-ED05E3E5CC01}" dt="2026-04-21T09:57:54.207" v="1347" actId="478"/>
-          <ac:spMkLst>
-            <pc:docMk/>
-            <pc:sldMk cId="0" sldId="316"/>
-            <ac:spMk id="5" creationId="{E9A43057-E16F-88C0-02B1-716D52799030}"/>
           </ac:spMkLst>
         </pc:spChg>
         <pc:spChg chg="add mod">
@@ -1019,14 +661,6 @@
             <ac:spMk id="3" creationId="{00000000-0000-0000-0000-000000000000}"/>
           </ac:spMkLst>
         </pc:spChg>
-        <pc:spChg chg="add del mod">
-          <ac:chgData name="Peter Bernhardt" userId="f2333933-0b12-4d6e-972f-f87625423892" providerId="ADAL" clId="{2C628E33-589C-449E-BBA5-ED05E3E5CC01}" dt="2026-04-21T10:10:31.389" v="1680" actId="478"/>
-          <ac:spMkLst>
-            <pc:docMk/>
-            <pc:sldMk cId="0" sldId="323"/>
-            <ac:spMk id="5" creationId="{6BFBBD4E-F3F9-D986-8AF9-9CB1F723FF1E}"/>
-          </ac:spMkLst>
-        </pc:spChg>
         <pc:spChg chg="add mod">
           <ac:chgData name="Peter Bernhardt" userId="f2333933-0b12-4d6e-972f-f87625423892" providerId="ADAL" clId="{2C628E33-589C-449E-BBA5-ED05E3E5CC01}" dt="2026-04-21T10:11:08.782" v="1685" actId="1076"/>
           <ac:spMkLst>
@@ -1042,28 +676,12 @@
           <pc:docMk/>
           <pc:sldMk cId="0" sldId="324"/>
         </pc:sldMkLst>
-        <pc:spChg chg="del mod">
-          <ac:chgData name="Peter Bernhardt" userId="f2333933-0b12-4d6e-972f-f87625423892" providerId="ADAL" clId="{2C628E33-589C-449E-BBA5-ED05E3E5CC01}" dt="2026-04-21T10:13:17.257" v="1743" actId="478"/>
-          <ac:spMkLst>
-            <pc:docMk/>
-            <pc:sldMk cId="0" sldId="324"/>
-            <ac:spMk id="3" creationId="{00000000-0000-0000-0000-000000000000}"/>
-          </ac:spMkLst>
-        </pc:spChg>
         <pc:spChg chg="add mod">
           <ac:chgData name="Peter Bernhardt" userId="f2333933-0b12-4d6e-972f-f87625423892" providerId="ADAL" clId="{2C628E33-589C-449E-BBA5-ED05E3E5CC01}" dt="2026-04-21T10:13:30.057" v="1746" actId="1076"/>
           <ac:spMkLst>
             <pc:docMk/>
             <pc:sldMk cId="0" sldId="324"/>
             <ac:spMk id="5" creationId="{0E194594-A0ED-1191-D5BC-F0A3251D6AA4}"/>
-          </ac:spMkLst>
-        </pc:spChg>
-        <pc:spChg chg="add del mod">
-          <ac:chgData name="Peter Bernhardt" userId="f2333933-0b12-4d6e-972f-f87625423892" providerId="ADAL" clId="{2C628E33-589C-449E-BBA5-ED05E3E5CC01}" dt="2026-04-21T10:13:21.121" v="1744" actId="478"/>
-          <ac:spMkLst>
-            <pc:docMk/>
-            <pc:sldMk cId="0" sldId="324"/>
-            <ac:spMk id="7" creationId="{C4C28B04-580C-97AA-A3F7-798D7505D8AA}"/>
           </ac:spMkLst>
         </pc:spChg>
       </pc:sldChg>
@@ -1079,14 +697,6 @@
             <pc:docMk/>
             <pc:sldMk cId="0" sldId="325"/>
             <ac:spMk id="2" creationId="{00000000-0000-0000-0000-000000000000}"/>
-          </ac:spMkLst>
-        </pc:spChg>
-        <pc:spChg chg="add del mod">
-          <ac:chgData name="Peter Bernhardt" userId="f2333933-0b12-4d6e-972f-f87625423892" providerId="ADAL" clId="{2C628E33-589C-449E-BBA5-ED05E3E5CC01}" dt="2026-04-21T08:40:41.234" v="44" actId="6264"/>
-          <ac:spMkLst>
-            <pc:docMk/>
-            <pc:sldMk cId="0" sldId="325"/>
-            <ac:spMk id="3" creationId="{8FB251E5-0F50-DE56-68CF-CB28C1A4D37A}"/>
           </ac:spMkLst>
         </pc:spChg>
         <pc:spChg chg="add mod ord">
@@ -1217,22 +827,6 @@
             <ac:spMk id="2" creationId="{A22B8489-4F8B-B7FE-1698-89117A47C320}"/>
           </ac:spMkLst>
         </pc:spChg>
-        <pc:spChg chg="del">
-          <ac:chgData name="Peter Bernhardt" userId="f2333933-0b12-4d6e-972f-f87625423892" providerId="ADAL" clId="{2C628E33-589C-449E-BBA5-ED05E3E5CC01}" dt="2026-04-21T09:44:59.012" v="1101" actId="478"/>
-          <ac:spMkLst>
-            <pc:docMk/>
-            <pc:sldMk cId="3793914736" sldId="333"/>
-            <ac:spMk id="3" creationId="{DB738211-EA8B-C38A-43A3-1E7E359FE43C}"/>
-          </ac:spMkLst>
-        </pc:spChg>
-        <pc:spChg chg="add del">
-          <ac:chgData name="Peter Bernhardt" userId="f2333933-0b12-4d6e-972f-f87625423892" providerId="ADAL" clId="{2C628E33-589C-449E-BBA5-ED05E3E5CC01}" dt="2026-04-21T09:45:05.236" v="1103" actId="478"/>
-          <ac:spMkLst>
-            <pc:docMk/>
-            <pc:sldMk cId="3793914736" sldId="333"/>
-            <ac:spMk id="4" creationId="{C5D4751F-BABC-D7B1-012E-F0510BC2B8F1}"/>
-          </ac:spMkLst>
-        </pc:spChg>
         <pc:picChg chg="add mod">
           <ac:chgData name="Peter Bernhardt" userId="f2333933-0b12-4d6e-972f-f87625423892" providerId="ADAL" clId="{2C628E33-589C-449E-BBA5-ED05E3E5CC01}" dt="2026-04-21T09:45:37.695" v="1107" actId="1076"/>
           <ac:picMkLst>
@@ -1241,24 +835,31 @@
             <ac:picMk id="6" creationId="{637390E1-DB75-C8EB-07DB-CC77E923857D}"/>
           </ac:picMkLst>
         </pc:picChg>
-        <pc:picChg chg="add del">
-          <ac:chgData name="Peter Bernhardt" userId="f2333933-0b12-4d6e-972f-f87625423892" providerId="ADAL" clId="{2C628E33-589C-449E-BBA5-ED05E3E5CC01}" dt="2026-04-21T09:44:56.978" v="1100" actId="478"/>
-          <ac:picMkLst>
-            <pc:docMk/>
-            <pc:sldMk cId="3793914736" sldId="333"/>
-            <ac:picMk id="2050" creationId="{EC144EDB-D834-1ACA-7EA3-181906E776AA}"/>
-          </ac:picMkLst>
-        </pc:picChg>
       </pc:sldChg>
     </pc:docChg>
   </pc:docChgLst>
   <pc:docChgLst>
     <pc:chgData name="Peter Bernhardt" userId="f2333933-0b12-4d6e-972f-f87625423892" providerId="ADAL" clId="{34DA1458-4058-4912-885C-C6A06A12728D}"/>
     <pc:docChg chg="undo custSel modSld">
-      <pc:chgData name="Peter Bernhardt" userId="f2333933-0b12-4d6e-972f-f87625423892" providerId="ADAL" clId="{34DA1458-4058-4912-885C-C6A06A12728D}" dt="2026-04-16T15:10:15.066" v="107" actId="20577"/>
+      <pc:chgData name="Peter Bernhardt" userId="f2333933-0b12-4d6e-972f-f87625423892" providerId="ADAL" clId="{34DA1458-4058-4912-885C-C6A06A12728D}" dt="2026-04-23T14:17:44.871" v="157" actId="20577"/>
       <pc:docMkLst>
         <pc:docMk/>
       </pc:docMkLst>
+      <pc:sldChg chg="modSp mod">
+        <pc:chgData name="Peter Bernhardt" userId="f2333933-0b12-4d6e-972f-f87625423892" providerId="ADAL" clId="{34DA1458-4058-4912-885C-C6A06A12728D}" dt="2026-04-23T14:17:44.871" v="157" actId="20577"/>
+        <pc:sldMkLst>
+          <pc:docMk/>
+          <pc:sldMk cId="0" sldId="312"/>
+        </pc:sldMkLst>
+        <pc:spChg chg="mod">
+          <ac:chgData name="Peter Bernhardt" userId="f2333933-0b12-4d6e-972f-f87625423892" providerId="ADAL" clId="{34DA1458-4058-4912-885C-C6A06A12728D}" dt="2026-04-23T14:17:44.871" v="157" actId="20577"/>
+          <ac:spMkLst>
+            <pc:docMk/>
+            <pc:sldMk cId="0" sldId="312"/>
+            <ac:spMk id="5" creationId="{A12D37CE-10DD-D13D-F193-322C5EFDC0E5}"/>
+          </ac:spMkLst>
+        </pc:spChg>
+      </pc:sldChg>
     </pc:docChg>
   </pc:docChgLst>
 </pc:chgInfo>
@@ -1966,7 +1567,7 @@
           <a:p>
             <a:fld id="{241EB5C9-1307-BA42-ABA2-0BC069CD8E7F}" type="datetimeFigureOut">
               <a:rPr lang="en-US" smtClean="0"/>
-              <a:t>4/21/2026</a:t>
+              <a:t>4/23/2026</a:t>
             </a:fld>
             <a:endParaRPr lang="en-US"/>
           </a:p>
@@ -2174,7 +1775,7 @@
           <a:p>
             <a:fld id="{241EB5C9-1307-BA42-ABA2-0BC069CD8E7F}" type="datetimeFigureOut">
               <a:rPr lang="en-US" smtClean="0"/>
-              <a:t>4/21/2026</a:t>
+              <a:t>4/23/2026</a:t>
             </a:fld>
             <a:endParaRPr lang="en-US"/>
           </a:p>
@@ -2430,7 +2031,7 @@
           <a:p>
             <a:fld id="{241EB5C9-1307-BA42-ABA2-0BC069CD8E7F}" type="datetimeFigureOut">
               <a:rPr lang="en-US" smtClean="0"/>
-              <a:t>4/21/2026</a:t>
+              <a:t>4/23/2026</a:t>
             </a:fld>
             <a:endParaRPr lang="en-US"/>
           </a:p>
@@ -2618,7 +2219,7 @@
           <a:p>
             <a:fld id="{241EB5C9-1307-BA42-ABA2-0BC069CD8E7F}" type="datetimeFigureOut">
               <a:rPr lang="en-US" smtClean="0"/>
-              <a:t>4/21/2026</a:t>
+              <a:t>4/23/2026</a:t>
             </a:fld>
             <a:endParaRPr lang="en-US"/>
           </a:p>
@@ -2975,7 +2576,7 @@
           <a:p>
             <a:fld id="{241EB5C9-1307-BA42-ABA2-0BC069CD8E7F}" type="datetimeFigureOut">
               <a:rPr lang="en-US" smtClean="0"/>
-              <a:t>4/21/2026</a:t>
+              <a:t>4/23/2026</a:t>
             </a:fld>
             <a:endParaRPr lang="en-US"/>
           </a:p>
@@ -3250,7 +2851,7 @@
           <a:p>
             <a:fld id="{241EB5C9-1307-BA42-ABA2-0BC069CD8E7F}" type="datetimeFigureOut">
               <a:rPr lang="en-US" smtClean="0"/>
-              <a:t>4/21/2026</a:t>
+              <a:t>4/23/2026</a:t>
             </a:fld>
             <a:endParaRPr lang="en-US"/>
           </a:p>
@@ -3629,7 +3230,7 @@
           <a:p>
             <a:fld id="{241EB5C9-1307-BA42-ABA2-0BC069CD8E7F}" type="datetimeFigureOut">
               <a:rPr lang="en-US" smtClean="0"/>
-              <a:t>4/21/2026</a:t>
+              <a:t>4/23/2026</a:t>
             </a:fld>
             <a:endParaRPr lang="en-US"/>
           </a:p>
@@ -3747,7 +3348,7 @@
           <a:p>
             <a:fld id="{241EB5C9-1307-BA42-ABA2-0BC069CD8E7F}" type="datetimeFigureOut">
               <a:rPr lang="en-US" smtClean="0"/>
-              <a:t>4/21/2026</a:t>
+              <a:t>4/23/2026</a:t>
             </a:fld>
             <a:endParaRPr lang="en-US"/>
           </a:p>
@@ -3918,7 +3519,7 @@
           <a:p>
             <a:fld id="{241EB5C9-1307-BA42-ABA2-0BC069CD8E7F}" type="datetimeFigureOut">
               <a:rPr lang="en-US" smtClean="0"/>
-              <a:t>4/21/2026</a:t>
+              <a:t>4/23/2026</a:t>
             </a:fld>
             <a:endParaRPr lang="en-US"/>
           </a:p>
@@ -4286,7 +3887,7 @@
           <a:p>
             <a:fld id="{241EB5C9-1307-BA42-ABA2-0BC069CD8E7F}" type="datetimeFigureOut">
               <a:rPr lang="en-US" smtClean="0"/>
-              <a:t>4/21/2026</a:t>
+              <a:t>4/23/2026</a:t>
             </a:fld>
             <a:endParaRPr lang="en-US"/>
           </a:p>
@@ -4663,7 +4264,7 @@
           <a:p>
             <a:fld id="{241EB5C9-1307-BA42-ABA2-0BC069CD8E7F}" type="datetimeFigureOut">
               <a:rPr lang="en-US" smtClean="0"/>
-              <a:t>4/21/2026</a:t>
+              <a:t>4/23/2026</a:t>
             </a:fld>
             <a:endParaRPr lang="en-US"/>
           </a:p>
@@ -4964,7 +4565,7 @@
           <a:p>
             <a:fld id="{241EB5C9-1307-BA42-ABA2-0BC069CD8E7F}" type="datetimeFigureOut">
               <a:rPr lang="en-US" smtClean="0"/>
-              <a:t>4/21/2026</a:t>
+              <a:t>4/23/2026</a:t>
             </a:fld>
             <a:endParaRPr lang="en-US"/>
           </a:p>
@@ -7868,7 +7469,7 @@
         <p:spPr>
           <a:xfrm>
             <a:off x="256310" y="1335725"/>
-            <a:ext cx="6477000" cy="3046988"/>
+            <a:ext cx="6477000" cy="2862322"/>
           </a:xfrm>
           <a:prstGeom prst="rect">
             <a:avLst/>
@@ -8608,6 +8209,16 @@
               </a:rPr>
               <a:t>BuergerDaten</a:t>
             </a:r>
+            <a:r>
+              <a:rPr lang="de-DE" sz="1200" b="0" dirty="0">
+                <a:solidFill>
+                  <a:srgbClr val="001080"/>
+                </a:solidFill>
+                <a:effectLst/>
+                <a:latin typeface="Consolas" panose="020B0609020204030204" pitchFamily="49" charset="0"/>
+              </a:rPr>
+              <a:t>(</a:t>
+            </a:r>
             <a:endParaRPr lang="de-DE" sz="1200" b="0" dirty="0">
               <a:solidFill>
                 <a:srgbClr val="3B3B3B"/>
@@ -8628,13 +8239,58 @@
                 <a:effectLst/>
                 <a:latin typeface="Consolas" panose="020B0609020204030204" pitchFamily="49" charset="0"/>
               </a:rPr>
-              <a:t>        {</a:t>
-            </a:r>
-          </a:p>
-          <a:p>
-            <a:pPr>
-              <a:buNone/>
-            </a:pPr>
+              <a:t>            </a:t>
+            </a:r>
+            <a:r>
+              <a:rPr lang="de-DE" sz="1200" b="0" dirty="0" err="1">
+                <a:solidFill>
+                  <a:srgbClr val="001080"/>
+                </a:solidFill>
+                <a:effectLst/>
+                <a:latin typeface="Consolas" panose="020B0609020204030204" pitchFamily="49" charset="0"/>
+              </a:rPr>
+              <a:t>meldeTask</a:t>
+            </a:r>
+            <a:r>
+              <a:rPr lang="de-DE" sz="1200" b="0" dirty="0" err="1">
+                <a:solidFill>
+                  <a:srgbClr val="000000"/>
+                </a:solidFill>
+                <a:effectLst/>
+                <a:latin typeface="Consolas" panose="020B0609020204030204" pitchFamily="49" charset="0"/>
+              </a:rPr>
+              <a:t>.</a:t>
+            </a:r>
+            <a:r>
+              <a:rPr lang="de-DE" sz="1200" b="0" dirty="0" err="1">
+                <a:solidFill>
+                  <a:srgbClr val="001080"/>
+                </a:solidFill>
+                <a:effectLst/>
+                <a:latin typeface="Consolas" panose="020B0609020204030204" pitchFamily="49" charset="0"/>
+              </a:rPr>
+              <a:t>Result</a:t>
+            </a:r>
+            <a:r>
+              <a:rPr lang="de-DE" sz="1200" b="0" dirty="0" err="1">
+                <a:solidFill>
+                  <a:srgbClr val="000000"/>
+                </a:solidFill>
+                <a:effectLst/>
+                <a:latin typeface="Consolas" panose="020B0609020204030204" pitchFamily="49" charset="0"/>
+              </a:rPr>
+              <a:t>.</a:t>
+            </a:r>
+            <a:r>
+              <a:rPr lang="de-DE" sz="1200" b="0" dirty="0" err="1">
+                <a:solidFill>
+                  <a:srgbClr val="001080"/>
+                </a:solidFill>
+                <a:effectLst/>
+                <a:latin typeface="Consolas" panose="020B0609020204030204" pitchFamily="49" charset="0"/>
+              </a:rPr>
+              <a:t>Name</a:t>
+            </a:r>
             <a:r>
               <a:rPr lang="de-DE" sz="1200" b="0" dirty="0">
                 <a:solidFill>
@@ -8643,212 +8299,16 @@
                 <a:effectLst/>
                 <a:latin typeface="Consolas" panose="020B0609020204030204" pitchFamily="49" charset="0"/>
               </a:rPr>
-              <a:t>            </a:t>
-            </a:r>
-            <a:r>
-              <a:rPr lang="de-DE" sz="1200" b="0" dirty="0">
-                <a:solidFill>
-                  <a:srgbClr val="001080"/>
-                </a:solidFill>
-                <a:effectLst/>
-                <a:latin typeface="Consolas" panose="020B0609020204030204" pitchFamily="49" charset="0"/>
-              </a:rPr>
-              <a:t>Name</a:t>
-            </a:r>
-            <a:r>
-              <a:rPr lang="de-DE" sz="1200" b="0" dirty="0">
-                <a:solidFill>
-                  <a:srgbClr val="3B3B3B"/>
-                </a:solidFill>
-                <a:effectLst/>
-                <a:latin typeface="Consolas" panose="020B0609020204030204" pitchFamily="49" charset="0"/>
-              </a:rPr>
-              <a:t> </a:t>
-            </a:r>
-            <a:r>
-              <a:rPr lang="de-DE" sz="1200" b="0" dirty="0">
-                <a:solidFill>
-                  <a:srgbClr val="000000"/>
-                </a:solidFill>
-                <a:effectLst/>
-                <a:latin typeface="Consolas" panose="020B0609020204030204" pitchFamily="49" charset="0"/>
-              </a:rPr>
-              <a:t>=</a:t>
-            </a:r>
-            <a:r>
-              <a:rPr lang="de-DE" sz="1200" b="0" dirty="0">
-                <a:solidFill>
-                  <a:srgbClr val="3B3B3B"/>
-                </a:solidFill>
-                <a:effectLst/>
-                <a:latin typeface="Consolas" panose="020B0609020204030204" pitchFamily="49" charset="0"/>
-              </a:rPr>
-              <a:t> </a:t>
-            </a:r>
-            <a:r>
-              <a:rPr lang="de-DE" sz="1200" b="0" dirty="0" err="1">
-                <a:solidFill>
-                  <a:srgbClr val="001080"/>
-                </a:solidFill>
-                <a:effectLst/>
-                <a:latin typeface="Consolas" panose="020B0609020204030204" pitchFamily="49" charset="0"/>
-              </a:rPr>
-              <a:t>meldeTask</a:t>
-            </a:r>
-            <a:r>
-              <a:rPr lang="de-DE" sz="1200" b="0" dirty="0" err="1">
-                <a:solidFill>
-                  <a:srgbClr val="000000"/>
-                </a:solidFill>
-                <a:effectLst/>
-                <a:latin typeface="Consolas" panose="020B0609020204030204" pitchFamily="49" charset="0"/>
-              </a:rPr>
-              <a:t>.</a:t>
-            </a:r>
-            <a:r>
-              <a:rPr lang="de-DE" sz="1200" b="0" dirty="0" err="1">
-                <a:solidFill>
-                  <a:srgbClr val="001080"/>
-                </a:solidFill>
-                <a:effectLst/>
-                <a:latin typeface="Consolas" panose="020B0609020204030204" pitchFamily="49" charset="0"/>
-              </a:rPr>
-              <a:t>Result</a:t>
-            </a:r>
-            <a:r>
-              <a:rPr lang="de-DE" sz="1200" b="0" dirty="0" err="1">
-                <a:solidFill>
-                  <a:srgbClr val="000000"/>
-                </a:solidFill>
-                <a:effectLst/>
-                <a:latin typeface="Consolas" panose="020B0609020204030204" pitchFamily="49" charset="0"/>
-              </a:rPr>
-              <a:t>.</a:t>
-            </a:r>
-            <a:r>
-              <a:rPr lang="de-DE" sz="1200" b="0" dirty="0" err="1">
-                <a:solidFill>
-                  <a:srgbClr val="001080"/>
-                </a:solidFill>
-                <a:effectLst/>
-                <a:latin typeface="Consolas" panose="020B0609020204030204" pitchFamily="49" charset="0"/>
-              </a:rPr>
-              <a:t>Name</a:t>
-            </a:r>
-            <a:r>
-              <a:rPr lang="de-DE" sz="1200" b="0" dirty="0">
-                <a:solidFill>
-                  <a:srgbClr val="3B3B3B"/>
-                </a:solidFill>
-                <a:effectLst/>
-                <a:latin typeface="Consolas" panose="020B0609020204030204" pitchFamily="49" charset="0"/>
-              </a:rPr>
-              <a:t>,</a:t>
-            </a:r>
-          </a:p>
-          <a:p>
-            <a:pPr>
-              <a:buNone/>
-            </a:pPr>
-            <a:r>
-              <a:rPr lang="de-DE" sz="1200" b="0" dirty="0">
-                <a:solidFill>
-                  <a:srgbClr val="3B3B3B"/>
-                </a:solidFill>
-                <a:effectLst/>
-                <a:latin typeface="Consolas" panose="020B0609020204030204" pitchFamily="49" charset="0"/>
-              </a:rPr>
-              <a:t>            </a:t>
-            </a:r>
-            <a:r>
-              <a:rPr lang="de-DE" sz="1200" b="0" dirty="0" err="1">
-                <a:solidFill>
-                  <a:srgbClr val="001080"/>
-                </a:solidFill>
-                <a:effectLst/>
-                <a:latin typeface="Consolas" panose="020B0609020204030204" pitchFamily="49" charset="0"/>
-              </a:rPr>
-              <a:t>SteuerKlasse</a:t>
-            </a:r>
-            <a:r>
-              <a:rPr lang="de-DE" sz="1200" b="0" dirty="0">
-                <a:solidFill>
-                  <a:srgbClr val="3B3B3B"/>
-                </a:solidFill>
-                <a:effectLst/>
-                <a:latin typeface="Consolas" panose="020B0609020204030204" pitchFamily="49" charset="0"/>
-              </a:rPr>
-              <a:t> </a:t>
-            </a:r>
-            <a:r>
-              <a:rPr lang="de-DE" sz="1200" b="0" dirty="0">
-                <a:solidFill>
-                  <a:srgbClr val="000000"/>
-                </a:solidFill>
-                <a:effectLst/>
-                <a:latin typeface="Consolas" panose="020B0609020204030204" pitchFamily="49" charset="0"/>
-              </a:rPr>
-              <a:t>=</a:t>
-            </a:r>
-            <a:r>
-              <a:rPr lang="de-DE" sz="1200" b="0" dirty="0">
-                <a:solidFill>
-                  <a:srgbClr val="3B3B3B"/>
-                </a:solidFill>
-                <a:effectLst/>
-                <a:latin typeface="Consolas" panose="020B0609020204030204" pitchFamily="49" charset="0"/>
-              </a:rPr>
-              <a:t> </a:t>
-            </a:r>
-            <a:r>
-              <a:rPr lang="de-DE" sz="1200" b="0" dirty="0" err="1">
-                <a:solidFill>
-                  <a:srgbClr val="001080"/>
-                </a:solidFill>
-                <a:effectLst/>
-                <a:latin typeface="Consolas" panose="020B0609020204030204" pitchFamily="49" charset="0"/>
-              </a:rPr>
-              <a:t>steuerTask</a:t>
-            </a:r>
-            <a:r>
-              <a:rPr lang="de-DE" sz="1200" b="0" dirty="0" err="1">
-                <a:solidFill>
-                  <a:srgbClr val="000000"/>
-                </a:solidFill>
-                <a:effectLst/>
-                <a:latin typeface="Consolas" panose="020B0609020204030204" pitchFamily="49" charset="0"/>
-              </a:rPr>
-              <a:t>.</a:t>
-            </a:r>
-            <a:r>
-              <a:rPr lang="de-DE" sz="1200" b="0" dirty="0" err="1">
-                <a:solidFill>
-                  <a:srgbClr val="001080"/>
-                </a:solidFill>
-                <a:effectLst/>
-                <a:latin typeface="Consolas" panose="020B0609020204030204" pitchFamily="49" charset="0"/>
-              </a:rPr>
-              <a:t>Result</a:t>
-            </a:r>
-            <a:r>
-              <a:rPr lang="de-DE" sz="1200" b="0" dirty="0" err="1">
-                <a:solidFill>
-                  <a:srgbClr val="000000"/>
-                </a:solidFill>
-                <a:effectLst/>
-                <a:latin typeface="Consolas" panose="020B0609020204030204" pitchFamily="49" charset="0"/>
-              </a:rPr>
-              <a:t>.</a:t>
-            </a:r>
-            <a:r>
-              <a:rPr lang="de-DE" sz="1200" b="0" dirty="0" err="1">
-                <a:solidFill>
-                  <a:srgbClr val="001080"/>
-                </a:solidFill>
-                <a:effectLst/>
-                <a:latin typeface="Consolas" panose="020B0609020204030204" pitchFamily="49" charset="0"/>
-              </a:rPr>
-              <a:t>Klasse</a:t>
+              <a:t>,   </a:t>
+            </a:r>
+            <a:r>
+              <a:rPr lang="de-DE" sz="1200" dirty="0">
+                <a:solidFill>
+                  <a:srgbClr val="008000"/>
+                </a:solidFill>
+                <a:latin typeface="Consolas" panose="020B0609020204030204" pitchFamily="49" charset="0"/>
+              </a:rPr>
+              <a:t>// Name</a:t>
             </a:r>
             <a:endParaRPr lang="de-DE" sz="1200" b="0" dirty="0">
               <a:solidFill>
@@ -8870,7 +8330,98 @@
                 <a:effectLst/>
                 <a:latin typeface="Consolas" panose="020B0609020204030204" pitchFamily="49" charset="0"/>
               </a:rPr>
-              <a:t>        };</a:t>
+              <a:t>            </a:t>
+            </a:r>
+            <a:r>
+              <a:rPr lang="de-DE" sz="1200" b="0" dirty="0" err="1">
+                <a:solidFill>
+                  <a:srgbClr val="001080"/>
+                </a:solidFill>
+                <a:effectLst/>
+                <a:latin typeface="Consolas" panose="020B0609020204030204" pitchFamily="49" charset="0"/>
+              </a:rPr>
+              <a:t>steuerTask</a:t>
+            </a:r>
+            <a:r>
+              <a:rPr lang="de-DE" sz="1200" b="0" dirty="0" err="1">
+                <a:solidFill>
+                  <a:srgbClr val="000000"/>
+                </a:solidFill>
+                <a:effectLst/>
+                <a:latin typeface="Consolas" panose="020B0609020204030204" pitchFamily="49" charset="0"/>
+              </a:rPr>
+              <a:t>.</a:t>
+            </a:r>
+            <a:r>
+              <a:rPr lang="de-DE" sz="1200" b="0" dirty="0" err="1">
+                <a:solidFill>
+                  <a:srgbClr val="001080"/>
+                </a:solidFill>
+                <a:effectLst/>
+                <a:latin typeface="Consolas" panose="020B0609020204030204" pitchFamily="49" charset="0"/>
+              </a:rPr>
+              <a:t>Result</a:t>
+            </a:r>
+            <a:r>
+              <a:rPr lang="de-DE" sz="1200" b="0" dirty="0" err="1">
+                <a:solidFill>
+                  <a:srgbClr val="000000"/>
+                </a:solidFill>
+                <a:effectLst/>
+                <a:latin typeface="Consolas" panose="020B0609020204030204" pitchFamily="49" charset="0"/>
+              </a:rPr>
+              <a:t>.</a:t>
+            </a:r>
+            <a:r>
+              <a:rPr lang="de-DE" sz="1200" b="0" dirty="0" err="1">
+                <a:solidFill>
+                  <a:srgbClr val="001080"/>
+                </a:solidFill>
+                <a:effectLst/>
+                <a:latin typeface="Consolas" panose="020B0609020204030204" pitchFamily="49" charset="0"/>
+              </a:rPr>
+              <a:t>Klasse</a:t>
+            </a:r>
+            <a:r>
+              <a:rPr lang="de-DE" sz="1200" b="0" dirty="0">
+                <a:solidFill>
+                  <a:srgbClr val="001080"/>
+                </a:solidFill>
+                <a:effectLst/>
+                <a:latin typeface="Consolas" panose="020B0609020204030204" pitchFamily="49" charset="0"/>
+              </a:rPr>
+              <a:t> </a:t>
+            </a:r>
+            <a:r>
+              <a:rPr lang="de-DE" sz="1200" dirty="0">
+                <a:solidFill>
+                  <a:srgbClr val="008000"/>
+                </a:solidFill>
+                <a:latin typeface="Consolas" panose="020B0609020204030204" pitchFamily="49" charset="0"/>
+              </a:rPr>
+              <a:t>// Steuerklasse</a:t>
+            </a:r>
+            <a:endParaRPr lang="de-DE" sz="1200" b="0" dirty="0">
+              <a:solidFill>
+                <a:srgbClr val="3B3B3B"/>
+              </a:solidFill>
+              <a:effectLst/>
+              <a:latin typeface="Consolas" panose="020B0609020204030204" pitchFamily="49" charset="0"/>
+            </a:endParaRPr>
+          </a:p>
+          <a:p>
+            <a:pPr>
+              <a:buNone/>
+            </a:pPr>
+            <a:r>
+              <a:rPr lang="de-DE" sz="1200" b="0" dirty="0">
+                <a:solidFill>
+                  <a:srgbClr val="3B3B3B"/>
+                </a:solidFill>
+                <a:effectLst/>
+                <a:latin typeface="Consolas" panose="020B0609020204030204" pitchFamily="49" charset="0"/>
+              </a:rPr>
+              <a:t>        );</a:t>
             </a:r>
           </a:p>
           <a:p>

</xml_diff>